<commit_message>
chore(dashboard): v2 QA pass
Co-Authored-By: Claude Fable 5 <noreply@anthropic.com>
</commit_message>
<xml_diff>
--- a/output/tremfya_ibd_split/deck.pptx
+++ b/output/tremfya_ibd_split/deck.pptx
@@ -142,9 +142,9 @@
           </c:marker>
           <c:cat>
             <c:strRef>
-              <c:f>Sheet1!$A$2:$A$111</c:f>
+              <c:f>Sheet1!$A$2:$A$107</c:f>
               <c:strCache>
-                <c:ptCount val="110"/>
+                <c:ptCount val="106"/>
                 <c:pt idx="0">
                   <c:v>05-03</c:v>
                 </c:pt>
@@ -462,28 +462,16 @@
                 </c:pt>
                 <c:pt idx="105">
                   <c:v>05-08</c:v>
-                </c:pt>
-                <c:pt idx="106">
-                  <c:v>05-15</c:v>
-                </c:pt>
-                <c:pt idx="107">
-                  <c:v>05-22</c:v>
-                </c:pt>
-                <c:pt idx="108">
-                  <c:v>05-29</c:v>
-                </c:pt>
-                <c:pt idx="109">
-                  <c:v>06-05</c:v>
                 </c:pt>
               </c:strCache>
             </c:strRef>
           </c:cat>
           <c:val>
             <c:numRef>
-              <c:f>Sheet1!$B$2:$B$111</c:f>
+              <c:f>Sheet1!$B$2:$B$107</c:f>
               <c:numCache>
                 <c:formatCode>General</c:formatCode>
-                <c:ptCount val="110"/>
+                <c:ptCount val="106"/>
                 <c:pt idx="0">
                   <c:v>2.612332</c:v>
                 </c:pt>
@@ -797,22 +785,10 @@
                   <c:v>2781.238172</c:v>
                 </c:pt>
                 <c:pt idx="104">
-                  <c:v>3026.023212</c:v>
+                  <c:v>3026.023211</c:v>
                 </c:pt>
                 <c:pt idx="105">
                   <c:v>3120.916383</c:v>
-                </c:pt>
-                <c:pt idx="106">
-                  <c:v>3183.334711</c:v>
-                </c:pt>
-                <c:pt idx="107">
-                  <c:v>3247.001405</c:v>
-                </c:pt>
-                <c:pt idx="108">
-                  <c:v>3311.941433</c:v>
-                </c:pt>
-                <c:pt idx="109">
-                  <c:v>3378.180262</c:v>
                 </c:pt>
               </c:numCache>
             </c:numRef>
@@ -845,9 +821,9 @@
           </c:marker>
           <c:cat>
             <c:strRef>
-              <c:f>Sheet1!$A$2:$A$111</c:f>
+              <c:f>Sheet1!$A$2:$A$107</c:f>
               <c:strCache>
-                <c:ptCount val="110"/>
+                <c:ptCount val="106"/>
                 <c:pt idx="0">
                   <c:v>05-03</c:v>
                 </c:pt>
@@ -1165,28 +1141,16 @@
                 </c:pt>
                 <c:pt idx="105">
                   <c:v>05-08</c:v>
-                </c:pt>
-                <c:pt idx="106">
-                  <c:v>05-15</c:v>
-                </c:pt>
-                <c:pt idx="107">
-                  <c:v>05-22</c:v>
-                </c:pt>
-                <c:pt idx="108">
-                  <c:v>05-29</c:v>
-                </c:pt>
-                <c:pt idx="109">
-                  <c:v>06-05</c:v>
                 </c:pt>
               </c:strCache>
             </c:strRef>
           </c:cat>
           <c:val>
             <c:numRef>
-              <c:f>Sheet1!$C$2:$C$111</c:f>
+              <c:f>Sheet1!$C$2:$C$107</c:f>
               <c:numCache>
                 <c:formatCode>General</c:formatCode>
-                <c:ptCount val="110"/>
+                <c:ptCount val="106"/>
                 <c:pt idx="0">
                   <c:v>5.290623</c:v>
                 </c:pt>
@@ -1500,22 +1464,10 @@
                   <c:v>3480.122648</c:v>
                 </c:pt>
                 <c:pt idx="104">
-                  <c:v>3786.418587</c:v>
+                  <c:v>3786.418588</c:v>
                 </c:pt>
                 <c:pt idx="105">
                   <c:v>3905.157025</c:v>
-                </c:pt>
-                <c:pt idx="106">
-                  <c:v>3983.260165</c:v>
-                </c:pt>
-                <c:pt idx="107">
-                  <c:v>4062.925369</c:v>
-                </c:pt>
-                <c:pt idx="108">
-                  <c:v>4144.183876</c:v>
-                </c:pt>
-                <c:pt idx="109">
-                  <c:v>4227.067553</c:v>
                 </c:pt>
               </c:numCache>
             </c:numRef>
@@ -1564,8 +1516,8 @@
         <c:lblAlgn val="ctr"/>
         <c:lblOffset val="100"/>
         <c:noMultiLvlLbl val="0"/>
-        <c:tickLblSkip val="12"/>
-        <c:tickMarkSkip val="12"/>
+        <c:tickLblSkip val="11"/>
+        <c:tickMarkSkip val="11"/>
       </c:catAx>
       <c:valAx>
         <c:axId val="2140495176"/>
@@ -4857,7 +4809,7 @@
                 </a:solidFill>
                 <a:latin typeface="Roboto"/>
               </a:rPr>
-              <a:t>Tremfya's weekly IBD volume has scaled from ~8 to ~7,605 TRx since May 2024. Within IBD, Crohn's pulled level in Oct 2025 and now leads ulcerative colitis.</a:t>
+              <a:t>Tremfya's weekly IBD volume has scaled from ~8 to ~7,026 TRx since May 2024. Within IBD, Crohn's pulled level in Oct 2025 and now leads ulcerative colitis.</a:t>
             </a:r>
           </a:p>
         </p:txBody>
@@ -5031,7 +4983,7 @@
                 </a:solidFill>
                 <a:latin typeface="Roboto"/>
               </a:rPr>
-              <a:t>CD ~4,227 vs UC ~3,378 TRx in the latest week (06-05).</a:t>
+              <a:t>CD ~3,905 vs UC ~3,121 TRx in the latest week (05-08).</a:t>
             </a:r>
           </a:p>
         </p:txBody>
@@ -5226,7 +5178,7 @@
                 </a:solidFill>
                 <a:latin typeface="Montserrat Medium"/>
               </a:rPr>
-              <a:t>~962x ramp</a:t>
+              <a:t>~889x ramp</a:t>
             </a:r>
           </a:p>
         </p:txBody>
@@ -5265,7 +5217,7 @@
                 </a:solidFill>
                 <a:latin typeface="Roboto"/>
               </a:rPr>
-              <a:t>Tremfya's IBD volume rose from ~8 to ~7,605 weekly TRx.</a:t>
+              <a:t>Tremfya's IBD volume rose from ~8 to ~7,026 weekly TRx.</a:t>
             </a:r>
           </a:p>
         </p:txBody>

</xml_diff>